<commit_message>
docs(slides): rebuild CampusEase presentation in the institutional defense format
Regenerate campusease_presentation.pptx (17 slides) using the shared
template theme (template_base.pptx) and the same layout system as the
reference deck: navy title band + accent underline, bullet/image/title
helpers, structured order (intro, problem, objectives, requirements,
use-case/ER/DFD/architecture/activity+sequence diagrams, tools, modules,
key workflows, app demo, conclusion). make_ppt.py reproduces it.
</commit_message>
<xml_diff>
--- a/docs/report/campusease_presentation.pptx
+++ b/docs/report/campusease_presentation.pptx
@@ -25,7 +25,6 @@
     <p:sldId id="270" r:id="rId20"/>
     <p:sldId id="271" r:id="rId21"/>
     <p:sldId id="272" r:id="rId22"/>
-    <p:sldId id="273" r:id="rId23"/>
   </p:sldIdLst>
   <p:sldSz cy="5143500" cx="9144000"/>
   <p:notesSz cx="6858000" cy="9144000"/>
@@ -5609,7 +5608,7 @@
               <a:spcAft>
                 <a:spcPts val="600"/>
               </a:spcAft>
-              <a:defRPr sz="4000" b="1">
+              <a:defRPr sz="3800" b="1">
                 <a:solidFill>
                   <a:srgbClr val="12335B"/>
                 </a:solidFill>
@@ -5624,14 +5623,14 @@
               <a:spcAft>
                 <a:spcPts val="0"/>
               </a:spcAft>
-              <a:defRPr sz="1800" b="0">
+              <a:defRPr sz="1700" b="0">
                 <a:solidFill>
                   <a:srgbClr val="202020"/>
                 </a:solidFill>
               </a:defRPr>
             </a:pPr>
             <a:r>
-              <a:t>A Web-Based College Automation System</a:t>
+              <a:t>A Web-Based College Automation System for</a:t>
             </a:r>
           </a:p>
           <a:p>
@@ -5639,14 +5638,14 @@
               <a:spcAft>
                 <a:spcPts val="1400"/>
               </a:spcAft>
-              <a:defRPr sz="1800" b="0">
+              <a:defRPr sz="1700" b="0">
                 <a:solidFill>
                   <a:srgbClr val="202020"/>
                 </a:solidFill>
               </a:defRPr>
             </a:pPr>
             <a:r>
-              <a:t>for Academic and Administrative Management</a:t>
+              <a:t>Academic and Administrative Management</a:t>
             </a:r>
           </a:p>
           <a:p>
@@ -5661,7 +5660,7 @@
               </a:defRPr>
             </a:pPr>
             <a:r>
-              <a:t>Bhupendra Malla, BIT (LC0003001648)</a:t>
+              <a:t>Bhupendra Malla, BIT 8th Semester (LC0003001648)</a:t>
             </a:r>
           </a:p>
           <a:p>
@@ -5752,7 +5751,7 @@
               </a:defRPr>
             </a:pPr>
             <a:r>
-              <a:t>Process Modeling: Data Flow Diagrams</a:t>
+              <a:t>System Architecture</a:t>
             </a:r>
           </a:p>
         </p:txBody>
@@ -5803,7 +5802,7 @@
       </p:sp>
       <p:pic>
         <p:nvPicPr>
-          <p:cNvPr id="4" name="Picture 3" descr="dfd_level0.png"/>
+          <p:cNvPr id="4" name="Picture 3" descr="architecture.png"/>
           <p:cNvPicPr>
             <a:picLocks noChangeAspect="1"/>
           </p:cNvPicPr>
@@ -5817,108 +5816,14 @@
         </p:blipFill>
         <p:spPr>
           <a:xfrm>
-            <a:off x="502920" y="2029519"/>
-            <a:ext cx="3931920" cy="1175901"/>
+            <a:off x="2327767" y="1234440"/>
+            <a:ext cx="4488466" cy="3040380"/>
           </a:xfrm>
           <a:prstGeom prst="rect">
             <a:avLst/>
           </a:prstGeom>
         </p:spPr>
       </p:pic>
-      <p:sp>
-        <p:nvSpPr>
-          <p:cNvPr id="5" name="TextBox 4"/>
-          <p:cNvSpPr txBox="1"/>
-          <p:nvPr/>
-        </p:nvSpPr>
-        <p:spPr>
-          <a:xfrm>
-            <a:off x="502920" y="4000500"/>
-            <a:ext cx="3931920" cy="274320"/>
-          </a:xfrm>
-          <a:prstGeom prst="rect">
-            <a:avLst/>
-          </a:prstGeom>
-          <a:noFill/>
-        </p:spPr>
-        <p:txBody>
-          <a:bodyPr wrap="none">
-            <a:spAutoFit/>
-          </a:bodyPr>
-          <a:lstStyle/>
-          <a:p>
-            <a:pPr algn="ctr">
-              <a:defRPr sz="1200">
-                <a:solidFill>
-                  <a:srgbClr val="202020"/>
-                </a:solidFill>
-              </a:defRPr>
-            </a:pPr>
-            <a:r>
-              <a:t>Level 0 (context)</a:t>
-            </a:r>
-          </a:p>
-        </p:txBody>
-      </p:sp>
-      <p:pic>
-        <p:nvPicPr>
-          <p:cNvPr id="6" name="Picture 5" descr="dfd_level1.png"/>
-          <p:cNvPicPr>
-            <a:picLocks noChangeAspect="1"/>
-          </p:cNvPicPr>
-          <p:nvPr/>
-        </p:nvPicPr>
-        <p:blipFill>
-          <a:blip r:embed="rId3"/>
-          <a:stretch>
-            <a:fillRect/>
-          </a:stretch>
-        </p:blipFill>
-        <p:spPr>
-          <a:xfrm>
-            <a:off x="5092330" y="1234440"/>
-            <a:ext cx="3165579" cy="2766060"/>
-          </a:xfrm>
-          <a:prstGeom prst="rect">
-            <a:avLst/>
-          </a:prstGeom>
-        </p:spPr>
-      </p:pic>
-      <p:sp>
-        <p:nvSpPr>
-          <p:cNvPr id="7" name="TextBox 6"/>
-          <p:cNvSpPr txBox="1"/>
-          <p:nvPr/>
-        </p:nvSpPr>
-        <p:spPr>
-          <a:xfrm>
-            <a:off x="4709160" y="4000500"/>
-            <a:ext cx="3931920" cy="274320"/>
-          </a:xfrm>
-          <a:prstGeom prst="rect">
-            <a:avLst/>
-          </a:prstGeom>
-          <a:noFill/>
-        </p:spPr>
-        <p:txBody>
-          <a:bodyPr wrap="none">
-            <a:spAutoFit/>
-          </a:bodyPr>
-          <a:lstStyle/>
-          <a:p>
-            <a:pPr algn="ctr">
-              <a:defRPr sz="1200">
-                <a:solidFill>
-                  <a:srgbClr val="202020"/>
-                </a:solidFill>
-              </a:defRPr>
-            </a:pPr>
-            <a:r>
-              <a:t>Level 1</a:t>
-            </a:r>
-          </a:p>
-        </p:txBody>
-      </p:sp>
     </p:spTree>
   </p:cSld>
   <p:clrMapOvr>
@@ -5975,7 +5880,7 @@
               </a:defRPr>
             </a:pPr>
             <a:r>
-              <a:t>System Architecture</a:t>
+              <a:t>Behavioural Modeling: Activity &amp; Sequence</a:t>
             </a:r>
           </a:p>
         </p:txBody>
@@ -6026,7 +5931,7 @@
       </p:sp>
       <p:pic>
         <p:nvPicPr>
-          <p:cNvPr id="4" name="Picture 3" descr="architecture.png"/>
+          <p:cNvPr id="4" name="Picture 3" descr="activity_diagram.png"/>
           <p:cNvPicPr>
             <a:picLocks noChangeAspect="1"/>
           </p:cNvPicPr>
@@ -6040,14 +5945,108 @@
         </p:blipFill>
         <p:spPr>
           <a:xfrm>
-            <a:off x="2327767" y="1234440"/>
-            <a:ext cx="4488466" cy="3040380"/>
+            <a:off x="1717015" y="1234440"/>
+            <a:ext cx="1503730" cy="2766060"/>
           </a:xfrm>
           <a:prstGeom prst="rect">
             <a:avLst/>
           </a:prstGeom>
         </p:spPr>
       </p:pic>
+      <p:sp>
+        <p:nvSpPr>
+          <p:cNvPr id="5" name="TextBox 4"/>
+          <p:cNvSpPr txBox="1"/>
+          <p:nvPr/>
+        </p:nvSpPr>
+        <p:spPr>
+          <a:xfrm>
+            <a:off x="502920" y="4000500"/>
+            <a:ext cx="3931920" cy="274320"/>
+          </a:xfrm>
+          <a:prstGeom prst="rect">
+            <a:avLst/>
+          </a:prstGeom>
+          <a:noFill/>
+        </p:spPr>
+        <p:txBody>
+          <a:bodyPr wrap="none">
+            <a:spAutoFit/>
+          </a:bodyPr>
+          <a:lstStyle/>
+          <a:p>
+            <a:pPr algn="ctr">
+              <a:defRPr sz="1200">
+                <a:solidFill>
+                  <a:srgbClr val="202020"/>
+                </a:solidFill>
+              </a:defRPr>
+            </a:pPr>
+            <a:r>
+              <a:t>Activity diagram</a:t>
+            </a:r>
+          </a:p>
+        </p:txBody>
+      </p:sp>
+      <p:pic>
+        <p:nvPicPr>
+          <p:cNvPr id="6" name="Picture 5" descr="sequence_diagram.png"/>
+          <p:cNvPicPr>
+            <a:picLocks noChangeAspect="1"/>
+          </p:cNvPicPr>
+          <p:nvPr/>
+        </p:nvPicPr>
+        <p:blipFill>
+          <a:blip r:embed="rId3"/>
+          <a:stretch>
+            <a:fillRect/>
+          </a:stretch>
+        </p:blipFill>
+        <p:spPr>
+          <a:xfrm>
+            <a:off x="5005502" y="1234440"/>
+            <a:ext cx="3339236" cy="2766060"/>
+          </a:xfrm>
+          <a:prstGeom prst="rect">
+            <a:avLst/>
+          </a:prstGeom>
+        </p:spPr>
+      </p:pic>
+      <p:sp>
+        <p:nvSpPr>
+          <p:cNvPr id="7" name="TextBox 6"/>
+          <p:cNvSpPr txBox="1"/>
+          <p:nvPr/>
+        </p:nvSpPr>
+        <p:spPr>
+          <a:xfrm>
+            <a:off x="4709160" y="4000500"/>
+            <a:ext cx="3931920" cy="274320"/>
+          </a:xfrm>
+          <a:prstGeom prst="rect">
+            <a:avLst/>
+          </a:prstGeom>
+          <a:noFill/>
+        </p:spPr>
+        <p:txBody>
+          <a:bodyPr wrap="none">
+            <a:spAutoFit/>
+          </a:bodyPr>
+          <a:lstStyle/>
+          <a:p>
+            <a:pPr algn="ctr">
+              <a:defRPr sz="1200">
+                <a:solidFill>
+                  <a:srgbClr val="202020"/>
+                </a:solidFill>
+              </a:defRPr>
+            </a:pPr>
+            <a:r>
+              <a:t>Sequence diagram</a:t>
+            </a:r>
+          </a:p>
+        </p:txBody>
+      </p:sp>
     </p:spTree>
   </p:cSld>
   <p:clrMapOvr>
@@ -6104,7 +6103,7 @@
               </a:defRPr>
             </a:pPr>
             <a:r>
-              <a:t>Key Process Models</a:t>
+              <a:t>Implementing Tools</a:t>
             </a:r>
           </a:p>
         </p:txBody>
@@ -6153,40 +6152,16 @@
           </a:p>
         </p:txBody>
       </p:sp>
-      <p:pic>
-        <p:nvPicPr>
-          <p:cNvPr id="4" name="Picture 3" descr="activity_diagram.png"/>
-          <p:cNvPicPr>
-            <a:picLocks noChangeAspect="1"/>
-          </p:cNvPicPr>
-          <p:nvPr/>
-        </p:nvPicPr>
-        <p:blipFill>
-          <a:blip r:embed="rId2"/>
-          <a:stretch>
-            <a:fillRect/>
-          </a:stretch>
-        </p:blipFill>
-        <p:spPr>
-          <a:xfrm>
-            <a:off x="1717015" y="1234440"/>
-            <a:ext cx="1503730" cy="2766060"/>
-          </a:xfrm>
-          <a:prstGeom prst="rect">
-            <a:avLst/>
-          </a:prstGeom>
-        </p:spPr>
-      </p:pic>
       <p:sp>
         <p:nvSpPr>
-          <p:cNvPr id="5" name="TextBox 4"/>
+          <p:cNvPr id="4" name="TextBox 3"/>
           <p:cNvSpPr txBox="1"/>
           <p:nvPr/>
         </p:nvSpPr>
         <p:spPr>
           <a:xfrm>
-            <a:off x="502920" y="4000500"/>
-            <a:ext cx="3931920" cy="274320"/>
+            <a:off x="502920" y="1234440"/>
+            <a:ext cx="8138160" cy="3040380"/>
           </a:xfrm>
           <a:prstGeom prst="rect">
             <a:avLst/>
@@ -6194,79 +6169,116 @@
           <a:noFill/>
         </p:spPr>
         <p:txBody>
-          <a:bodyPr wrap="none">
-            <a:spAutoFit/>
+          <a:bodyPr wrap="square">
+            <a:normAutofit/>
           </a:bodyPr>
           <a:lstStyle/>
           <a:p>
-            <a:pPr algn="ctr">
-              <a:defRPr sz="1200">
+            <a:pPr>
+              <a:lnSpc>
+                <a:spcPct val="105000"/>
+              </a:lnSpc>
+              <a:spcAft>
+                <a:spcPts val="700"/>
+              </a:spcAft>
+              <a:defRPr sz="1700">
                 <a:solidFill>
                   <a:srgbClr val="202020"/>
                 </a:solidFill>
               </a:defRPr>
             </a:pPr>
             <a:r>
-              <a:t>Activity: face attendance</a:t>
+              <a:t>•  Angular + TypeScript: role-specific single-page frontend portals.</a:t>
             </a:r>
           </a:p>
-        </p:txBody>
-      </p:sp>
-      <p:pic>
-        <p:nvPicPr>
-          <p:cNvPr id="6" name="Picture 5" descr="sequence_diagram.png"/>
-          <p:cNvPicPr>
-            <a:picLocks noChangeAspect="1"/>
-          </p:cNvPicPr>
-          <p:nvPr/>
-        </p:nvPicPr>
-        <p:blipFill>
-          <a:blip r:embed="rId3"/>
-          <a:stretch>
-            <a:fillRect/>
-          </a:stretch>
-        </p:blipFill>
-        <p:spPr>
-          <a:xfrm>
-            <a:off x="5005502" y="1234440"/>
-            <a:ext cx="3339236" cy="2766060"/>
-          </a:xfrm>
-          <a:prstGeom prst="rect">
-            <a:avLst/>
-          </a:prstGeom>
-        </p:spPr>
-      </p:pic>
-      <p:sp>
-        <p:nvSpPr>
-          <p:cNvPr id="7" name="TextBox 6"/>
-          <p:cNvSpPr txBox="1"/>
-          <p:nvPr/>
-        </p:nvSpPr>
-        <p:spPr>
-          <a:xfrm>
-            <a:off x="4709160" y="4000500"/>
-            <a:ext cx="3931920" cy="274320"/>
-          </a:xfrm>
-          <a:prstGeom prst="rect">
-            <a:avLst/>
-          </a:prstGeom>
-          <a:noFill/>
-        </p:spPr>
-        <p:txBody>
-          <a:bodyPr wrap="none">
-            <a:spAutoFit/>
-          </a:bodyPr>
-          <a:lstStyle/>
-          <a:p>
-            <a:pPr algn="ctr">
-              <a:defRPr sz="1200">
+          <a:p>
+            <a:pPr>
+              <a:lnSpc>
+                <a:spcPct val="105000"/>
+              </a:lnSpc>
+              <a:spcAft>
+                <a:spcPts val="700"/>
+              </a:spcAft>
+              <a:defRPr sz="1700">
                 <a:solidFill>
                   <a:srgbClr val="202020"/>
                 </a:solidFill>
               </a:defRPr>
             </a:pPr>
             <a:r>
-              <a:t>Sequence: online fee payment</a:t>
+              <a:t>•  Node.js + Express: REST API; Socket.io for real-time messaging and presence.</a:t>
+            </a:r>
+          </a:p>
+          <a:p>
+            <a:pPr>
+              <a:lnSpc>
+                <a:spcPct val="105000"/>
+              </a:lnSpc>
+              <a:spcAft>
+                <a:spcPts val="700"/>
+              </a:spcAft>
+              <a:defRPr sz="1700">
+                <a:solidFill>
+                  <a:srgbClr val="202020"/>
+                </a:solidFill>
+              </a:defRPr>
+            </a:pPr>
+            <a:r>
+              <a:t>•  MongoDB + Mongoose: document database with schema-based data access.</a:t>
+            </a:r>
+          </a:p>
+          <a:p>
+            <a:pPr>
+              <a:lnSpc>
+                <a:spcPct val="105000"/>
+              </a:lnSpc>
+              <a:spcAft>
+                <a:spcPts val="700"/>
+              </a:spcAft>
+              <a:defRPr sz="1700">
+                <a:solidFill>
+                  <a:srgbClr val="202020"/>
+                </a:solidFill>
+              </a:defRPr>
+            </a:pPr>
+            <a:r>
+              <a:t>•  JWT + bcrypt: stateless authentication and one-way password hashing.</a:t>
+            </a:r>
+          </a:p>
+          <a:p>
+            <a:pPr>
+              <a:lnSpc>
+                <a:spcPct val="105000"/>
+              </a:lnSpc>
+              <a:spcAft>
+                <a:spcPts val="700"/>
+              </a:spcAft>
+              <a:defRPr sz="1700">
+                <a:solidFill>
+                  <a:srgbClr val="202020"/>
+                </a:solidFill>
+              </a:defRPr>
+            </a:pPr>
+            <a:r>
+              <a:t>•  Multer (uploads), Nodemailer (verification/OTP email), Highcharts (dashboards).</a:t>
+            </a:r>
+          </a:p>
+          <a:p>
+            <a:pPr>
+              <a:lnSpc>
+                <a:spcPct val="105000"/>
+              </a:lnSpc>
+              <a:spcAft>
+                <a:spcPts val="700"/>
+              </a:spcAft>
+              <a:defRPr sz="1700">
+                <a:solidFill>
+                  <a:srgbClr val="202020"/>
+                </a:solidFill>
+              </a:defRPr>
+            </a:pPr>
+            <a:r>
+              <a:t>•  Khalti: external gateway for online fee payment. Git/GitHub, VS Code, Angular CLI.</a:t>
             </a:r>
           </a:p>
         </p:txBody>
@@ -6327,7 +6339,7 @@
               </a:defRPr>
             </a:pPr>
             <a:r>
-              <a:t>System Flowchart</a:t>
+              <a:t>Implementation: Module Details</a:t>
             </a:r>
           </a:p>
         </p:txBody>
@@ -6376,30 +6388,137 @@
           </a:p>
         </p:txBody>
       </p:sp>
-      <p:pic>
-        <p:nvPicPr>
-          <p:cNvPr id="4" name="Picture 3" descr="flowchart.png"/>
-          <p:cNvPicPr>
-            <a:picLocks noChangeAspect="1"/>
-          </p:cNvPicPr>
+      <p:sp>
+        <p:nvSpPr>
+          <p:cNvPr id="4" name="TextBox 3"/>
+          <p:cNvSpPr txBox="1"/>
           <p:nvPr/>
-        </p:nvPicPr>
-        <p:blipFill>
-          <a:blip r:embed="rId2"/>
-          <a:stretch>
-            <a:fillRect/>
-          </a:stretch>
-        </p:blipFill>
+        </p:nvSpPr>
         <p:spPr>
           <a:xfrm>
-            <a:off x="3893143" y="1234440"/>
-            <a:ext cx="1357714" cy="3040380"/>
+            <a:off x="502920" y="1234440"/>
+            <a:ext cx="8138160" cy="3040380"/>
           </a:xfrm>
           <a:prstGeom prst="rect">
             <a:avLst/>
           </a:prstGeom>
+          <a:noFill/>
         </p:spPr>
-      </p:pic>
+        <p:txBody>
+          <a:bodyPr wrap="square">
+            <a:normAutofit/>
+          </a:bodyPr>
+          <a:lstStyle/>
+          <a:p>
+            <a:pPr>
+              <a:lnSpc>
+                <a:spcPct val="105000"/>
+              </a:lnSpc>
+              <a:spcAft>
+                <a:spcPts val="700"/>
+              </a:spcAft>
+              <a:defRPr sz="1700">
+                <a:solidFill>
+                  <a:srgbClr val="202020"/>
+                </a:solidFill>
+              </a:defRPr>
+            </a:pPr>
+            <a:r>
+              <a:t>•  Authentication &amp; Role: registration, email verification, JWT login, RBAC middleware by role/department.</a:t>
+            </a:r>
+          </a:p>
+          <a:p>
+            <a:pPr>
+              <a:lnSpc>
+                <a:spcPct val="105000"/>
+              </a:lnSpc>
+              <a:spcAft>
+                <a:spcPts val="700"/>
+              </a:spcAft>
+              <a:defRPr sz="1700">
+                <a:solidFill>
+                  <a:srgbClr val="202020"/>
+                </a:solidFill>
+              </a:defRPr>
+            </a:pPr>
+            <a:r>
+              <a:t>•  Academic: enrollment-key based subject enrollment, class scheduling, academic records.</a:t>
+            </a:r>
+          </a:p>
+          <a:p>
+            <a:pPr>
+              <a:lnSpc>
+                <a:spcPct val="105000"/>
+              </a:lnSpc>
+              <a:spcAft>
+                <a:spcPts val="700"/>
+              </a:spcAft>
+              <a:defRPr sz="1700">
+                <a:solidFill>
+                  <a:srgbClr val="202020"/>
+                </a:solidFill>
+              </a:defRPr>
+            </a:pPr>
+            <a:r>
+              <a:t>•  Attendance: manual roll, short-lived OTP, and webcam face-recognition matching.</a:t>
+            </a:r>
+          </a:p>
+          <a:p>
+            <a:pPr>
+              <a:lnSpc>
+                <a:spcPct val="105000"/>
+              </a:lnSpc>
+              <a:spcAft>
+                <a:spcPts val="700"/>
+              </a:spcAft>
+              <a:defRPr sz="1700">
+                <a:solidFill>
+                  <a:srgbClr val="202020"/>
+                </a:solidFill>
+              </a:defRPr>
+            </a:pPr>
+            <a:r>
+              <a:t>•  Assignments &amp; Marks: post/submit assignments, marks entry, automatic internal-marks calculation.</a:t>
+            </a:r>
+          </a:p>
+          <a:p>
+            <a:pPr>
+              <a:lnSpc>
+                <a:spcPct val="105000"/>
+              </a:lnSpc>
+              <a:spcAft>
+                <a:spcPts val="700"/>
+              </a:spcAft>
+              <a:defRPr sz="1700">
+                <a:solidFill>
+                  <a:srgbClr val="202020"/>
+                </a:solidFill>
+              </a:defRPr>
+            </a:pPr>
+            <a:r>
+              <a:t>•  Fee Payment: Khalti-initiated online payment, receipt + status, admin/finance approval.</a:t>
+            </a:r>
+          </a:p>
+          <a:p>
+            <a:pPr>
+              <a:lnSpc>
+                <a:spcPct val="105000"/>
+              </a:lnSpc>
+              <a:spcAft>
+                <a:spcPts val="700"/>
+              </a:spcAft>
+              <a:defRPr sz="1700">
+                <a:solidFill>
+                  <a:srgbClr val="202020"/>
+                </a:solidFill>
+              </a:defRPr>
+            </a:pPr>
+            <a:r>
+              <a:t>•  Communication &amp; Admin: Socket.io messaging, forums/events/clubs, user/department management, job-CV portal, digital ID cards.</a:t>
+            </a:r>
+          </a:p>
+        </p:txBody>
+      </p:sp>
     </p:spTree>
   </p:cSld>
   <p:clrMapOvr>
@@ -6456,7 +6575,7 @@
               </a:defRPr>
             </a:pPr>
             <a:r>
-              <a:t>Implementing Tools</a:t>
+              <a:t>Key Workflows</a:t>
             </a:r>
           </a:p>
         </p:txBody>
@@ -6541,7 +6660,7 @@
               </a:defRPr>
             </a:pPr>
             <a:r>
-              <a:t>•  Angular + TypeScript + Bootstrap: single-page, role-specific frontend portals.</a:t>
+              <a:t>•  Role-based access control: JWT carries role + department; middleware gates every endpoint.</a:t>
             </a:r>
           </a:p>
           <a:p>
@@ -6559,7 +6678,7 @@
               </a:defRPr>
             </a:pPr>
             <a:r>
-              <a:t>•  Node.js + Express: REST API; Socket.io for real-time messaging and presence.</a:t>
+              <a:t>•  Khalti payment: frontend -&gt; backend initiate -&gt; Khalti checkout -&gt; return callback -&gt; lookup verify -&gt; fee marked Paid.</a:t>
             </a:r>
           </a:p>
           <a:p>
@@ -6577,7 +6696,7 @@
               </a:defRPr>
             </a:pPr>
             <a:r>
-              <a:t>•  MongoDB + Mongoose: NoSQL document database and object-document mapper.</a:t>
+              <a:t>•  Internal marks: assignment marks + attendance marks combined into a computed internal score.</a:t>
             </a:r>
           </a:p>
           <a:p>
@@ -6595,25 +6714,7 @@
               </a:defRPr>
             </a:pPr>
             <a:r>
-              <a:t>•  JWT + bcrypt: stateless authentication and one-way password hashing.</a:t>
-            </a:r>
-          </a:p>
-          <a:p>
-            <a:pPr>
-              <a:lnSpc>
-                <a:spcPct val="105000"/>
-              </a:lnSpc>
-              <a:spcAft>
-                <a:spcPts val="700"/>
-              </a:spcAft>
-              <a:defRPr sz="1700">
-                <a:solidFill>
-                  <a:srgbClr val="202020"/>
-                </a:solidFill>
-              </a:defRPr>
-            </a:pPr>
-            <a:r>
-              <a:t>•  Khalti (payment), Nodemailer (email/OTP), Multer (uploads), Highcharts (dashboards).</a:t>
+              <a:t>•  Attendance OTP: server issues a 5-minute code; student submits it (with location) to mark present.</a:t>
             </a:r>
           </a:p>
         </p:txBody>
@@ -6674,7 +6775,7 @@
               </a:defRPr>
             </a:pPr>
             <a:r>
-              <a:t>Implementation: Module Details</a:t>
+              <a:t>Application Demo: Admin Dashboard</a:t>
             </a:r>
           </a:p>
         </p:txBody>
@@ -6723,137 +6824,30 @@
           </a:p>
         </p:txBody>
       </p:sp>
-      <p:sp>
-        <p:nvSpPr>
-          <p:cNvPr id="4" name="TextBox 3"/>
-          <p:cNvSpPr txBox="1"/>
+      <p:pic>
+        <p:nvPicPr>
+          <p:cNvPr id="4" name="Picture 3" descr="app_admin_dashboard.png"/>
+          <p:cNvPicPr>
+            <a:picLocks noChangeAspect="1"/>
+          </p:cNvPicPr>
           <p:nvPr/>
-        </p:nvSpPr>
+        </p:nvPicPr>
+        <p:blipFill>
+          <a:blip r:embed="rId2"/>
+          <a:stretch>
+            <a:fillRect/>
+          </a:stretch>
+        </p:blipFill>
         <p:spPr>
           <a:xfrm>
-            <a:off x="502920" y="1234440"/>
-            <a:ext cx="8138160" cy="3040380"/>
+            <a:off x="1912776" y="1234440"/>
+            <a:ext cx="5318448" cy="3040380"/>
           </a:xfrm>
           <a:prstGeom prst="rect">
             <a:avLst/>
           </a:prstGeom>
-          <a:noFill/>
         </p:spPr>
-        <p:txBody>
-          <a:bodyPr wrap="square">
-            <a:normAutofit/>
-          </a:bodyPr>
-          <a:lstStyle/>
-          <a:p>
-            <a:pPr>
-              <a:lnSpc>
-                <a:spcPct val="105000"/>
-              </a:lnSpc>
-              <a:spcAft>
-                <a:spcPts val="700"/>
-              </a:spcAft>
-              <a:defRPr sz="1700">
-                <a:solidFill>
-                  <a:srgbClr val="202020"/>
-                </a:solidFill>
-              </a:defRPr>
-            </a:pPr>
-            <a:r>
-              <a:t>•  Authentication &amp; Role: registration, email verify, login, JWT, role/department checks.</a:t>
-            </a:r>
-          </a:p>
-          <a:p>
-            <a:pPr>
-              <a:lnSpc>
-                <a:spcPct val="105000"/>
-              </a:lnSpc>
-              <a:spcAft>
-                <a:spcPts val="700"/>
-              </a:spcAft>
-              <a:defRPr sz="1700">
-                <a:solidFill>
-                  <a:srgbClr val="202020"/>
-                </a:solidFill>
-              </a:defRPr>
-            </a:pPr>
-            <a:r>
-              <a:t>•  Academic: enrollment by key, class scheduling, academic records.</a:t>
-            </a:r>
-          </a:p>
-          <a:p>
-            <a:pPr>
-              <a:lnSpc>
-                <a:spcPct val="105000"/>
-              </a:lnSpc>
-              <a:spcAft>
-                <a:spcPts val="700"/>
-              </a:spcAft>
-              <a:defRPr sz="1700">
-                <a:solidFill>
-                  <a:srgbClr val="202020"/>
-                </a:solidFill>
-              </a:defRPr>
-            </a:pPr>
-            <a:r>
-              <a:t>•  Attendance: manual, OTP, and face-recognition (webcam capture and matching).</a:t>
-            </a:r>
-          </a:p>
-          <a:p>
-            <a:pPr>
-              <a:lnSpc>
-                <a:spcPct val="105000"/>
-              </a:lnSpc>
-              <a:spcAft>
-                <a:spcPts val="700"/>
-              </a:spcAft>
-              <a:defRPr sz="1700">
-                <a:solidFill>
-                  <a:srgbClr val="202020"/>
-                </a:solidFill>
-              </a:defRPr>
-            </a:pPr>
-            <a:r>
-              <a:t>•  Assignments &amp; Marks: posting/submission, marks entry, automatic internal-marks calc.</a:t>
-            </a:r>
-          </a:p>
-          <a:p>
-            <a:pPr>
-              <a:lnSpc>
-                <a:spcPct val="105000"/>
-              </a:lnSpc>
-              <a:spcAft>
-                <a:spcPts val="700"/>
-              </a:spcAft>
-              <a:defRPr sz="1700">
-                <a:solidFill>
-                  <a:srgbClr val="202020"/>
-                </a:solidFill>
-              </a:defRPr>
-            </a:pPr>
-            <a:r>
-              <a:t>•  Fee Payment: Khalti online payment with admin approval workflow.</a:t>
-            </a:r>
-          </a:p>
-          <a:p>
-            <a:pPr>
-              <a:lnSpc>
-                <a:spcPct val="105000"/>
-              </a:lnSpc>
-              <a:spcAft>
-                <a:spcPts val="700"/>
-              </a:spcAft>
-              <a:defRPr sz="1700">
-                <a:solidFill>
-                  <a:srgbClr val="202020"/>
-                </a:solidFill>
-              </a:defRPr>
-            </a:pPr>
-            <a:r>
-              <a:t>•  Communication &amp; Admin: real-time chat, discussions, events, clubs, user management.</a:t>
-            </a:r>
-          </a:p>
-        </p:txBody>
-      </p:sp>
+      </p:pic>
     </p:spTree>
   </p:cSld>
   <p:clrMapOvr>
@@ -6910,7 +6904,7 @@
               </a:defRPr>
             </a:pPr>
             <a:r>
-              <a:t>Application Demo</a:t>
+              <a:t>Application Demo: User Management</a:t>
             </a:r>
           </a:p>
         </p:txBody>
@@ -6961,7 +6955,7 @@
       </p:sp>
       <p:pic>
         <p:nvPicPr>
-          <p:cNvPr id="4" name="Picture 3" descr="app_admin_dashboard.png"/>
+          <p:cNvPr id="4" name="Picture 3" descr="app_user_management.png"/>
           <p:cNvPicPr>
             <a:picLocks noChangeAspect="1"/>
           </p:cNvPicPr>
@@ -6975,108 +6969,14 @@
         </p:blipFill>
         <p:spPr>
           <a:xfrm>
-            <a:off x="502920" y="1493596"/>
-            <a:ext cx="3931920" cy="2247747"/>
+            <a:off x="1912776" y="1234440"/>
+            <a:ext cx="5318448" cy="3040380"/>
           </a:xfrm>
           <a:prstGeom prst="rect">
             <a:avLst/>
           </a:prstGeom>
         </p:spPr>
       </p:pic>
-      <p:sp>
-        <p:nvSpPr>
-          <p:cNvPr id="5" name="TextBox 4"/>
-          <p:cNvSpPr txBox="1"/>
-          <p:nvPr/>
-        </p:nvSpPr>
-        <p:spPr>
-          <a:xfrm>
-            <a:off x="502920" y="4000500"/>
-            <a:ext cx="3931920" cy="274320"/>
-          </a:xfrm>
-          <a:prstGeom prst="rect">
-            <a:avLst/>
-          </a:prstGeom>
-          <a:noFill/>
-        </p:spPr>
-        <p:txBody>
-          <a:bodyPr wrap="none">
-            <a:spAutoFit/>
-          </a:bodyPr>
-          <a:lstStyle/>
-          <a:p>
-            <a:pPr algn="ctr">
-              <a:defRPr sz="1200">
-                <a:solidFill>
-                  <a:srgbClr val="202020"/>
-                </a:solidFill>
-              </a:defRPr>
-            </a:pPr>
-            <a:r>
-              <a:t>Admin console</a:t>
-            </a:r>
-          </a:p>
-        </p:txBody>
-      </p:sp>
-      <p:pic>
-        <p:nvPicPr>
-          <p:cNvPr id="6" name="Picture 5" descr="app_user_management.png"/>
-          <p:cNvPicPr>
-            <a:picLocks noChangeAspect="1"/>
-          </p:cNvPicPr>
-          <p:nvPr/>
-        </p:nvPicPr>
-        <p:blipFill>
-          <a:blip r:embed="rId3"/>
-          <a:stretch>
-            <a:fillRect/>
-          </a:stretch>
-        </p:blipFill>
-        <p:spPr>
-          <a:xfrm>
-            <a:off x="4709160" y="1493596"/>
-            <a:ext cx="3931920" cy="2247747"/>
-          </a:xfrm>
-          <a:prstGeom prst="rect">
-            <a:avLst/>
-          </a:prstGeom>
-        </p:spPr>
-      </p:pic>
-      <p:sp>
-        <p:nvSpPr>
-          <p:cNvPr id="7" name="TextBox 6"/>
-          <p:cNvSpPr txBox="1"/>
-          <p:nvPr/>
-        </p:nvSpPr>
-        <p:spPr>
-          <a:xfrm>
-            <a:off x="4709160" y="4000500"/>
-            <a:ext cx="3931920" cy="274320"/>
-          </a:xfrm>
-          <a:prstGeom prst="rect">
-            <a:avLst/>
-          </a:prstGeom>
-          <a:noFill/>
-        </p:spPr>
-        <p:txBody>
-          <a:bodyPr wrap="none">
-            <a:spAutoFit/>
-          </a:bodyPr>
-          <a:lstStyle/>
-          <a:p>
-            <a:pPr algn="ctr">
-              <a:defRPr sz="1200">
-                <a:solidFill>
-                  <a:srgbClr val="202020"/>
-                </a:solidFill>
-              </a:defRPr>
-            </a:pPr>
-            <a:r>
-              <a:t>User management</a:t>
-            </a:r>
-          </a:p>
-        </p:txBody>
-      </p:sp>
     </p:spTree>
   </p:cSld>
   <p:clrMapOvr>
@@ -7133,7 +7033,7 @@
               </a:defRPr>
             </a:pPr>
             <a:r>
-              <a:t>Testing</a:t>
+              <a:t>Conclusion</a:t>
             </a:r>
           </a:p>
         </p:txBody>
@@ -7218,7 +7118,7 @@
               </a:defRPr>
             </a:pPr>
             <a:r>
-              <a:t>•  Tested module by module, then end to end through the UI for each role.</a:t>
+              <a:t>•  A complete, working platform unifying enrollment, attendance, assignments, marks, fees, and communication.</a:t>
             </a:r>
           </a:p>
           <a:p>
@@ -7236,7 +7136,7 @@
               </a:defRPr>
             </a:pPr>
             <a:r>
-              <a:t>•  Unit tests: auth/JWT/role checks, enrollment, attendance, internal-marks, fee, messaging.</a:t>
+              <a:t>•  Role-based portals, three attendance methods, automatic internal marks, and verified Khalti online payment.</a:t>
             </a:r>
           </a:p>
           <a:p>
@@ -7254,7 +7154,7 @@
               </a:defRPr>
             </a:pPr>
             <a:r>
-              <a:t>•  System tests: register-verify-login, attendance by face/OTP, assignment flow, fee pay+approve, real-time chat, user management.</a:t>
+              <a:t>•  Real-time messaging and engagement features, with secure JWT auth and per-role access control.</a:t>
             </a:r>
           </a:p>
           <a:p>
@@ -7272,137 +7172,9 @@
               </a:defRPr>
             </a:pPr>
             <a:r>
-              <a:t>•  All unit and system test cases passed; role-based access reliably allowed/denied actions.</a:t>
+              <a:t>•  All unit and system test cases passed; end-to-end tested across every role.</a:t>
             </a:r>
           </a:p>
-        </p:txBody>
-      </p:sp>
-    </p:spTree>
-  </p:cSld>
-  <p:clrMapOvr>
-    <a:masterClrMapping/>
-  </p:clrMapOvr>
-</p:sld>
-</file>
-
-<file path=ppt/slides/slide18.xml><?xml version="1.0" encoding="utf-8"?>
-<p:sld xmlns:a="http://schemas.openxmlformats.org/drawingml/2006/main" xmlns:p="http://schemas.openxmlformats.org/presentationml/2006/main" xmlns:r="http://schemas.openxmlformats.org/officeDocument/2006/relationships">
-  <p:cSld>
-    <p:bg>
-      <p:bgPr>
-        <a:solidFill>
-          <a:srgbClr val="FFFFFF"/>
-        </a:solidFill>
-        <a:effectLst/>
-      </p:bgPr>
-    </p:bg>
-    <p:spTree>
-      <p:nvGrpSpPr>
-        <p:cNvPr id="1" name=""/>
-        <p:cNvGrpSpPr/>
-        <p:nvPr/>
-      </p:nvGrpSpPr>
-      <p:grpSpPr/>
-      <p:sp>
-        <p:nvSpPr>
-          <p:cNvPr id="2" name="TextBox 1"/>
-          <p:cNvSpPr txBox="1"/>
-          <p:nvPr/>
-        </p:nvSpPr>
-        <p:spPr>
-          <a:xfrm>
-            <a:off x="502920" y="320040"/>
-            <a:ext cx="8138160" cy="777240"/>
-          </a:xfrm>
-          <a:prstGeom prst="rect">
-            <a:avLst/>
-          </a:prstGeom>
-          <a:noFill/>
-        </p:spPr>
-        <p:txBody>
-          <a:bodyPr wrap="square" anchor="ctr">
-            <a:noAutofit/>
-          </a:bodyPr>
-          <a:lstStyle/>
-          <a:p>
-            <a:pPr>
-              <a:defRPr sz="2600" b="1">
-                <a:solidFill>
-                  <a:srgbClr val="12335B"/>
-                </a:solidFill>
-              </a:defRPr>
-            </a:pPr>
-            <a:r>
-              <a:t>Conclusion</a:t>
-            </a:r>
-          </a:p>
-        </p:txBody>
-      </p:sp>
-      <p:sp>
-        <p:nvSpPr>
-          <p:cNvPr id="3" name="Rectangle 2"/>
-          <p:cNvSpPr/>
-          <p:nvPr/>
-        </p:nvSpPr>
-        <p:spPr>
-          <a:xfrm>
-            <a:off x="502920" y="1097280"/>
-            <a:ext cx="2011680" cy="38100"/>
-          </a:xfrm>
-          <a:prstGeom prst="rect">
-            <a:avLst/>
-          </a:prstGeom>
-          <a:solidFill>
-            <a:srgbClr val="2E6FB5"/>
-          </a:solidFill>
-          <a:ln>
-            <a:noFill/>
-          </a:ln>
-          <a:effectLst/>
-        </p:spPr>
-        <p:style>
-          <a:lnRef idx="1">
-            <a:schemeClr val="accent1"/>
-          </a:lnRef>
-          <a:fillRef idx="3">
-            <a:schemeClr val="accent1"/>
-          </a:fillRef>
-          <a:effectRef idx="2">
-            <a:schemeClr val="accent1"/>
-          </a:effectRef>
-          <a:fontRef idx="minor">
-            <a:schemeClr val="lt1"/>
-          </a:fontRef>
-        </p:style>
-        <p:txBody>
-          <a:bodyPr rtlCol="0" anchor="ctr"/>
-          <a:lstStyle/>
-          <a:p>
-            <a:pPr algn="ctr"/>
-          </a:p>
-        </p:txBody>
-      </p:sp>
-      <p:sp>
-        <p:nvSpPr>
-          <p:cNvPr id="4" name="TextBox 3"/>
-          <p:cNvSpPr txBox="1"/>
-          <p:nvPr/>
-        </p:nvSpPr>
-        <p:spPr>
-          <a:xfrm>
-            <a:off x="502920" y="1234440"/>
-            <a:ext cx="8138160" cy="3040380"/>
-          </a:xfrm>
-          <a:prstGeom prst="rect">
-            <a:avLst/>
-          </a:prstGeom>
-          <a:noFill/>
-        </p:spPr>
-        <p:txBody>
-          <a:bodyPr wrap="square">
-            <a:normAutofit/>
-          </a:bodyPr>
-          <a:lstStyle/>
           <a:p>
             <a:pPr>
               <a:lnSpc>
@@ -7418,61 +7190,7 @@
               </a:defRPr>
             </a:pPr>
             <a:r>
-              <a:t>•  A complete, working platform unifying academics, administration, and communication for a college.</a:t>
-            </a:r>
-          </a:p>
-          <a:p>
-            <a:pPr>
-              <a:lnSpc>
-                <a:spcPct val="105000"/>
-              </a:lnSpc>
-              <a:spcAft>
-                <a:spcPts val="700"/>
-              </a:spcAft>
-              <a:defRPr sz="1700">
-                <a:solidFill>
-                  <a:srgbClr val="202020"/>
-                </a:solidFill>
-              </a:defRPr>
-            </a:pPr>
-            <a:r>
-              <a:t>•  Role-based access, three attendance methods, automatic internal marks, online fee payment, and real-time messaging.</a:t>
-            </a:r>
-          </a:p>
-          <a:p>
-            <a:pPr>
-              <a:lnSpc>
-                <a:spcPct val="105000"/>
-              </a:lnSpc>
-              <a:spcAft>
-                <a:spcPts val="700"/>
-              </a:spcAft>
-              <a:defRPr sz="1700">
-                <a:solidFill>
-                  <a:srgbClr val="202020"/>
-                </a:solidFill>
-              </a:defRPr>
-            </a:pPr>
-            <a:r>
-              <a:t>•  Built on Angular + Node/Express + Socket.io + MongoDB, secured with JWT and bcrypt; all test cases passed.</a:t>
-            </a:r>
-          </a:p>
-          <a:p>
-            <a:pPr>
-              <a:lnSpc>
-                <a:spcPct val="105000"/>
-              </a:lnSpc>
-              <a:spcAft>
-                <a:spcPts val="700"/>
-              </a:spcAft>
-              <a:defRPr sz="1700">
-                <a:solidFill>
-                  <a:srgbClr val="202020"/>
-                </a:solidFill>
-              </a:defRPr>
-            </a:pPr>
-            <a:r>
-              <a:t>•  Future work: mobile app, push notifications, advanced analytics, scalable deployment, more payment options.</a:t>
+              <a:t>•  Future work: real-time analytics, mobile app, ML-based insights, and multi-campus scaling.</a:t>
             </a:r>
           </a:p>
         </p:txBody>
@@ -7618,7 +7336,7 @@
               </a:defRPr>
             </a:pPr>
             <a:r>
-              <a:t>•  Colleges run on many overlapping manual processes: enrollment, attendance, assignments, exams, fees, scheduling, and communication.</a:t>
+              <a:t>•  Colleges run on many disconnected processes: enrollment, attendance, marks, fees, notices, communication.</a:t>
             </a:r>
           </a:p>
           <a:p>
@@ -7636,7 +7354,7 @@
               </a:defRPr>
             </a:pPr>
             <a:r>
-              <a:t>•  Handled on paper or across disconnected tools, this is slow, error-prone, and hard to track.</a:t>
+              <a:t>•  Most are still manual or spread across spreadsheets, paper, and separate tools.</a:t>
             </a:r>
           </a:p>
           <a:p>
@@ -7654,7 +7372,7 @@
               </a:defRPr>
             </a:pPr>
             <a:r>
-              <a:t>◦  Records get duplicated or lost; attendance and marks are tedious to compile; updates are easy to miss.</a:t>
+              <a:t>◦  Data is duplicated, hard to track, and slow to act on for students, faculty, and staff.</a:t>
             </a:r>
           </a:p>
           <a:p>
@@ -7672,7 +7390,7 @@
               </a:defRPr>
             </a:pPr>
             <a:r>
-              <a:t>•  CampusEase brings these activities onto a single web platform with role-based access for students, faculty, secretaries, and administrators.</a:t>
+              <a:t>•  CampusEase: a single web platform that centralises academic and administrative operations.</a:t>
             </a:r>
           </a:p>
           <a:p>
@@ -7690,7 +7408,7 @@
               </a:defRPr>
             </a:pPr>
             <a:r>
-              <a:t>•  Adds modern conveniences: face-recognition attendance, online fee payment, and real-time messaging.</a:t>
+              <a:t>•  Role-based portals for students, faculty, secretaries, and administrators with automated services.</a:t>
             </a:r>
           </a:p>
         </p:txBody>
@@ -7836,7 +7554,79 @@
               </a:defRPr>
             </a:pPr>
             <a:r>
-              <a:t>•  Fragmented information: records spread across registers, spreadsheets, and unrelated tools, with no single source of truth.</a:t>
+              <a:t>•  College operations are fragmented and largely manual:</a:t>
+            </a:r>
+          </a:p>
+          <a:p>
+            <a:pPr lvl="1">
+              <a:lnSpc>
+                <a:spcPct val="105000"/>
+              </a:lnSpc>
+              <a:spcAft>
+                <a:spcPts val="300"/>
+              </a:spcAft>
+              <a:defRPr sz="1400">
+                <a:solidFill>
+                  <a:srgbClr val="202020"/>
+                </a:solidFill>
+              </a:defRPr>
+            </a:pPr>
+            <a:r>
+              <a:t>◦  Enrollment, attendance, and marks are tracked by hand or in disconnected files.</a:t>
+            </a:r>
+          </a:p>
+          <a:p>
+            <a:pPr lvl="1">
+              <a:lnSpc>
+                <a:spcPct val="105000"/>
+              </a:lnSpc>
+              <a:spcAft>
+                <a:spcPts val="300"/>
+              </a:spcAft>
+              <a:defRPr sz="1400">
+                <a:solidFill>
+                  <a:srgbClr val="202020"/>
+                </a:solidFill>
+              </a:defRPr>
+            </a:pPr>
+            <a:r>
+              <a:t>◦  Fee collection lacks a digital, trackable, approval-based workflow.</a:t>
+            </a:r>
+          </a:p>
+          <a:p>
+            <a:pPr lvl="1">
+              <a:lnSpc>
+                <a:spcPct val="105000"/>
+              </a:lnSpc>
+              <a:spcAft>
+                <a:spcPts val="300"/>
+              </a:spcAft>
+              <a:defRPr sz="1400">
+                <a:solidFill>
+                  <a:srgbClr val="202020"/>
+                </a:solidFill>
+              </a:defRPr>
+            </a:pPr>
+            <a:r>
+              <a:t>◦  Communication (notices, messaging, events) is scattered across channels.</a:t>
+            </a:r>
+          </a:p>
+          <a:p>
+            <a:pPr lvl="1">
+              <a:lnSpc>
+                <a:spcPct val="105000"/>
+              </a:lnSpc>
+              <a:spcAft>
+                <a:spcPts val="300"/>
+              </a:spcAft>
+              <a:defRPr sz="1400">
+                <a:solidFill>
+                  <a:srgbClr val="202020"/>
+                </a:solidFill>
+              </a:defRPr>
+            </a:pPr>
+            <a:r>
+              <a:t>◦  No single role-aware portal, so each user juggles multiple systems.</a:t>
             </a:r>
           </a:p>
           <a:p>
@@ -7854,61 +7644,7 @@
               </a:defRPr>
             </a:pPr>
             <a:r>
-              <a:t>•  Manual, repetitive work: attendance, internal marks, fee reconciliation, and reports done by hand.</a:t>
-            </a:r>
-          </a:p>
-          <a:p>
-            <a:pPr>
-              <a:lnSpc>
-                <a:spcPct val="105000"/>
-              </a:lnSpc>
-              <a:spcAft>
-                <a:spcPts val="700"/>
-              </a:spcAft>
-              <a:defRPr sz="1700">
-                <a:solidFill>
-                  <a:srgbClr val="202020"/>
-                </a:solidFill>
-              </a:defRPr>
-            </a:pPr>
-            <a:r>
-              <a:t>•  Errors and inconsistency from re-entering the same data in many places, with no audit trail.</a:t>
-            </a:r>
-          </a:p>
-          <a:p>
-            <a:pPr>
-              <a:lnSpc>
-                <a:spcPct val="105000"/>
-              </a:lnSpc>
-              <a:spcAft>
-                <a:spcPts val="700"/>
-              </a:spcAft>
-              <a:defRPr sz="1700">
-                <a:solidFill>
-                  <a:srgbClr val="202020"/>
-                </a:solidFill>
-              </a:defRPr>
-            </a:pPr>
-            <a:r>
-              <a:t>•  Weak communication: updates reach students through notice boards and informal channels.</a:t>
-            </a:r>
-          </a:p>
-          <a:p>
-            <a:pPr>
-              <a:lnSpc>
-                <a:spcPct val="105000"/>
-              </a:lnSpc>
-              <a:spcAft>
-                <a:spcPts val="700"/>
-              </a:spcAft>
-              <a:defRPr sz="1700">
-                <a:solidFill>
-                  <a:srgbClr val="202020"/>
-                </a:solidFill>
-              </a:defRPr>
-            </a:pPr>
-            <a:r>
-              <a:t>•  Limited access control: hard to ensure each role sees and does only what it should.</a:t>
+              <a:t>•  Need: one secure, role-based web system that unifies these workflows and automates routine tasks.</a:t>
             </a:r>
           </a:p>
         </p:txBody>
@@ -8054,7 +7790,7 @@
               </a:defRPr>
             </a:pPr>
             <a:r>
-              <a:t>•  General: a web-based college automation system centralising academic and administrative operations with role-based services.</a:t>
+              <a:t>•  General: a web-based college automation system that centralises academic and administrative operations with role-based, automated services.</a:t>
             </a:r>
           </a:p>
           <a:p>
@@ -8090,7 +7826,7 @@
               </a:defRPr>
             </a:pPr>
             <a:r>
-              <a:t>◦  Design a role-based access model for students, faculty, secretaries, and administrators.</a:t>
+              <a:t>◦  Design role-based access control for students, faculty, secretaries, and administrators.</a:t>
             </a:r>
           </a:p>
           <a:p>
@@ -8108,7 +7844,7 @@
               </a:defRPr>
             </a:pPr>
             <a:r>
-              <a:t>◦  Implement enrollment, scheduling, and academic-record management.</a:t>
+              <a:t>◦  Implement subject enrollment, class scheduling, and academic-record management.</a:t>
             </a:r>
           </a:p>
           <a:p>
@@ -8126,7 +7862,7 @@
               </a:defRPr>
             </a:pPr>
             <a:r>
-              <a:t>◦  Provide manual, OTP, and face-recognition attendance.</a:t>
+              <a:t>◦  Provide manual, OTP, and face-recognition attendance methods.</a:t>
             </a:r>
           </a:p>
           <a:p>
@@ -8162,7 +7898,25 @@
               </a:defRPr>
             </a:pPr>
             <a:r>
-              <a:t>◦  Integrate online fee payment (Khalti) and real-time communication.</a:t>
+              <a:t>◦  Integrate secure online fee payment via Khalti with an admin approval workflow.</a:t>
+            </a:r>
+          </a:p>
+          <a:p>
+            <a:pPr lvl="1">
+              <a:lnSpc>
+                <a:spcPct val="105000"/>
+              </a:lnSpc>
+              <a:spcAft>
+                <a:spcPts val="300"/>
+              </a:spcAft>
+              <a:defRPr sz="1400">
+                <a:solidFill>
+                  <a:srgbClr val="202020"/>
+                </a:solidFill>
+              </a:defRPr>
+            </a:pPr>
+            <a:r>
+              <a:t>◦  Enable real-time messaging, discussion forums, events, and clubs.</a:t>
             </a:r>
           </a:p>
         </p:txBody>
@@ -8308,7 +8062,7 @@
               </a:defRPr>
             </a:pPr>
             <a:r>
-              <a:t>•  Registration with email verification, authentication, and role-based access.</a:t>
+              <a:t>•  Role-based registration, email/OTP verification, and authentication.</a:t>
             </a:r>
           </a:p>
           <a:p>
@@ -8326,7 +8080,7 @@
               </a:defRPr>
             </a:pPr>
             <a:r>
-              <a:t>•  Subject enrollment (enrollment keys), class scheduling, and academic records.</a:t>
+              <a:t>•  Subject enrollment via enrollment keys, class scheduling, academic records.</a:t>
             </a:r>
           </a:p>
           <a:p>
@@ -8362,7 +8116,7 @@
               </a:defRPr>
             </a:pPr>
             <a:r>
-              <a:t>•  Assignment posting and submission, marks entry, and internal-marks calculation.</a:t>
+              <a:t>•  Assignment distribution/submission, marks entry, automatic internal-marks calculation.</a:t>
             </a:r>
           </a:p>
           <a:p>
@@ -8380,7 +8134,7 @@
               </a:defRPr>
             </a:pPr>
             <a:r>
-              <a:t>•  Online fee payment via Khalti with administrative approval.</a:t>
+              <a:t>•  Online fee payment via Khalti with status tracking and admin approval.</a:t>
             </a:r>
           </a:p>
           <a:p>
@@ -8398,7 +8152,7 @@
               </a:defRPr>
             </a:pPr>
             <a:r>
-              <a:t>•  Real-time messaging, discussions, events, clubs, ID cards, and reports.</a:t>
+              <a:t>•  Real-time messaging, discussion forums, events, clubs, job/CV portal, digital ID cards.</a:t>
             </a:r>
           </a:p>
         </p:txBody>
@@ -8544,7 +8298,7 @@
               </a:defRPr>
             </a:pPr>
             <a:r>
-              <a:t>•  Performance: respond within a couple of seconds; deliver messages in real time.</a:t>
+              <a:t>•  Performance: respond to typical actions within a few seconds at institution scale.</a:t>
             </a:r>
           </a:p>
           <a:p>
@@ -8562,7 +8316,7 @@
               </a:defRPr>
             </a:pPr>
             <a:r>
-              <a:t>•  Usability: intuitive, role-specific interfaces with no special training.</a:t>
+              <a:t>•  Usability: role-specific dashboards usable with basic technical knowledge.</a:t>
             </a:r>
           </a:p>
           <a:p>
@@ -8580,7 +8334,7 @@
               </a:defRPr>
             </a:pPr>
             <a:r>
-              <a:t>•  Security: bcrypt-hashed passwords, JWT-authenticated requests, role-based access.</a:t>
+              <a:t>•  Security: bcrypt-hashed passwords, JWT auth, role- and department-based access control.</a:t>
             </a:r>
           </a:p>
           <a:p>
@@ -8598,7 +8352,7 @@
               </a:defRPr>
             </a:pPr>
             <a:r>
-              <a:t>•  Reliability: handle invalid input and unavailable external services gracefully.</a:t>
+              <a:t>•  Reliability: consistent data via Mongoose schemas and validation.</a:t>
             </a:r>
           </a:p>
           <a:p>
@@ -8616,7 +8370,7 @@
               </a:defRPr>
             </a:pPr>
             <a:r>
-              <a:t>•  Maintainability and portability: modular code; any Node.js + MongoDB host.</a:t>
+              <a:t>•  Maintainability and portability: modular Angular + Express, runs on any Node.js runtime.</a:t>
             </a:r>
           </a:p>
         </p:txBody>
@@ -8677,7 +8431,7 @@
               </a:defRPr>
             </a:pPr>
             <a:r>
-              <a:t>Development Methodology</a:t>
+              <a:t>Requirement Modeling: Use-Case Diagram</a:t>
             </a:r>
           </a:p>
         </p:txBody>
@@ -8726,101 +8480,30 @@
           </a:p>
         </p:txBody>
       </p:sp>
-      <p:sp>
-        <p:nvSpPr>
-          <p:cNvPr id="4" name="TextBox 3"/>
-          <p:cNvSpPr txBox="1"/>
+      <p:pic>
+        <p:nvPicPr>
+          <p:cNvPr id="4" name="Picture 3" descr="use_case_diagram.png"/>
+          <p:cNvPicPr>
+            <a:picLocks noChangeAspect="1"/>
+          </p:cNvPicPr>
           <p:nvPr/>
-        </p:nvSpPr>
+        </p:nvPicPr>
+        <p:blipFill>
+          <a:blip r:embed="rId2"/>
+          <a:stretch>
+            <a:fillRect/>
+          </a:stretch>
+        </p:blipFill>
         <p:spPr>
           <a:xfrm>
-            <a:off x="502920" y="1234440"/>
-            <a:ext cx="8138160" cy="3040380"/>
+            <a:off x="3830917" y="1234440"/>
+            <a:ext cx="1482165" cy="3040380"/>
           </a:xfrm>
           <a:prstGeom prst="rect">
             <a:avLst/>
           </a:prstGeom>
-          <a:noFill/>
         </p:spPr>
-        <p:txBody>
-          <a:bodyPr wrap="square">
-            <a:normAutofit/>
-          </a:bodyPr>
-          <a:lstStyle/>
-          <a:p>
-            <a:pPr>
-              <a:lnSpc>
-                <a:spcPct val="105000"/>
-              </a:lnSpc>
-              <a:spcAft>
-                <a:spcPts val="700"/>
-              </a:spcAft>
-              <a:defRPr sz="1700">
-                <a:solidFill>
-                  <a:srgbClr val="202020"/>
-                </a:solidFill>
-              </a:defRPr>
-            </a:pPr>
-            <a:r>
-              <a:t>•  Agile, sprint-based development suited to a system of many distinct modules.</a:t>
-            </a:r>
-          </a:p>
-          <a:p>
-            <a:pPr lvl="1">
-              <a:lnSpc>
-                <a:spcPct val="105000"/>
-              </a:lnSpc>
-              <a:spcAft>
-                <a:spcPts val="300"/>
-              </a:spcAft>
-              <a:defRPr sz="1400">
-                <a:solidFill>
-                  <a:srgbClr val="202020"/>
-                </a:solidFill>
-              </a:defRPr>
-            </a:pPr>
-            <a:r>
-              <a:t>◦  Each sprint delivered working modules: data model, API, Angular screens, then testing.</a:t>
-            </a:r>
-          </a:p>
-          <a:p>
-            <a:pPr>
-              <a:lnSpc>
-                <a:spcPct val="105000"/>
-              </a:lnSpc>
-              <a:spcAft>
-                <a:spcPts val="700"/>
-              </a:spcAft>
-              <a:defRPr sz="1700">
-                <a:solidFill>
-                  <a:srgbClr val="202020"/>
-                </a:solidFill>
-              </a:defRPr>
-            </a:pPr>
-            <a:r>
-              <a:t>•  Role model and shared user data model were built first, since later features depend on them.</a:t>
-            </a:r>
-          </a:p>
-          <a:p>
-            <a:pPr>
-              <a:lnSpc>
-                <a:spcPct val="105000"/>
-              </a:lnSpc>
-              <a:spcAft>
-                <a:spcPts val="700"/>
-              </a:spcAft>
-              <a:defRPr sz="1700">
-                <a:solidFill>
-                  <a:srgbClr val="202020"/>
-                </a:solidFill>
-              </a:defRPr>
-            </a:pPr>
-            <a:r>
-              <a:t>•  Git and GitHub used throughout for incremental tracking and continuous integration.</a:t>
-            </a:r>
-          </a:p>
-        </p:txBody>
-      </p:sp>
+      </p:pic>
     </p:spTree>
   </p:cSld>
   <p:clrMapOvr>
@@ -8877,7 +8560,7 @@
               </a:defRPr>
             </a:pPr>
             <a:r>
-              <a:t>Use-Case Model</a:t>
+              <a:t>Data Modeling: ER Diagram</a:t>
             </a:r>
           </a:p>
         </p:txBody>
@@ -8928,7 +8611,7 @@
       </p:sp>
       <p:pic>
         <p:nvPicPr>
-          <p:cNvPr id="4" name="Picture 3" descr="use_case_diagram.png"/>
+          <p:cNvPr id="4" name="Picture 3" descr="er_diagram.png"/>
           <p:cNvPicPr>
             <a:picLocks noChangeAspect="1"/>
           </p:cNvPicPr>
@@ -8942,8 +8625,8 @@
         </p:blipFill>
         <p:spPr>
           <a:xfrm>
-            <a:off x="3830917" y="1234440"/>
-            <a:ext cx="1482165" cy="3040380"/>
+            <a:off x="1660655" y="1234440"/>
+            <a:ext cx="5822690" cy="3040380"/>
           </a:xfrm>
           <a:prstGeom prst="rect">
             <a:avLst/>
@@ -9006,7 +8689,7 @@
               </a:defRPr>
             </a:pPr>
             <a:r>
-              <a:t>Data Modeling: ER Diagram</a:t>
+              <a:t>Process Modeling: Data Flow Diagrams</a:t>
             </a:r>
           </a:p>
         </p:txBody>
@@ -9057,7 +8740,7 @@
       </p:sp>
       <p:pic>
         <p:nvPicPr>
-          <p:cNvPr id="4" name="Picture 3" descr="er_diagram.png"/>
+          <p:cNvPr id="4" name="Picture 3" descr="dfd_level0.png"/>
           <p:cNvPicPr>
             <a:picLocks noChangeAspect="1"/>
           </p:cNvPicPr>
@@ -9071,14 +8754,108 @@
         </p:blipFill>
         <p:spPr>
           <a:xfrm>
-            <a:off x="1660655" y="1234440"/>
-            <a:ext cx="5822690" cy="3040380"/>
+            <a:off x="502920" y="2029519"/>
+            <a:ext cx="3931920" cy="1175901"/>
           </a:xfrm>
           <a:prstGeom prst="rect">
             <a:avLst/>
           </a:prstGeom>
         </p:spPr>
       </p:pic>
+      <p:sp>
+        <p:nvSpPr>
+          <p:cNvPr id="5" name="TextBox 4"/>
+          <p:cNvSpPr txBox="1"/>
+          <p:nvPr/>
+        </p:nvSpPr>
+        <p:spPr>
+          <a:xfrm>
+            <a:off x="502920" y="4000500"/>
+            <a:ext cx="3931920" cy="274320"/>
+          </a:xfrm>
+          <a:prstGeom prst="rect">
+            <a:avLst/>
+          </a:prstGeom>
+          <a:noFill/>
+        </p:spPr>
+        <p:txBody>
+          <a:bodyPr wrap="none">
+            <a:spAutoFit/>
+          </a:bodyPr>
+          <a:lstStyle/>
+          <a:p>
+            <a:pPr algn="ctr">
+              <a:defRPr sz="1200">
+                <a:solidFill>
+                  <a:srgbClr val="202020"/>
+                </a:solidFill>
+              </a:defRPr>
+            </a:pPr>
+            <a:r>
+              <a:t>Level 0 (context)</a:t>
+            </a:r>
+          </a:p>
+        </p:txBody>
+      </p:sp>
+      <p:pic>
+        <p:nvPicPr>
+          <p:cNvPr id="6" name="Picture 5" descr="dfd_level1.png"/>
+          <p:cNvPicPr>
+            <a:picLocks noChangeAspect="1"/>
+          </p:cNvPicPr>
+          <p:nvPr/>
+        </p:nvPicPr>
+        <p:blipFill>
+          <a:blip r:embed="rId3"/>
+          <a:stretch>
+            <a:fillRect/>
+          </a:stretch>
+        </p:blipFill>
+        <p:spPr>
+          <a:xfrm>
+            <a:off x="5092330" y="1234440"/>
+            <a:ext cx="3165579" cy="2766060"/>
+          </a:xfrm>
+          <a:prstGeom prst="rect">
+            <a:avLst/>
+          </a:prstGeom>
+        </p:spPr>
+      </p:pic>
+      <p:sp>
+        <p:nvSpPr>
+          <p:cNvPr id="7" name="TextBox 6"/>
+          <p:cNvSpPr txBox="1"/>
+          <p:nvPr/>
+        </p:nvSpPr>
+        <p:spPr>
+          <a:xfrm>
+            <a:off x="4709160" y="4000500"/>
+            <a:ext cx="3931920" cy="274320"/>
+          </a:xfrm>
+          <a:prstGeom prst="rect">
+            <a:avLst/>
+          </a:prstGeom>
+          <a:noFill/>
+        </p:spPr>
+        <p:txBody>
+          <a:bodyPr wrap="none">
+            <a:spAutoFit/>
+          </a:bodyPr>
+          <a:lstStyle/>
+          <a:p>
+            <a:pPr algn="ctr">
+              <a:defRPr sz="1200">
+                <a:solidFill>
+                  <a:srgbClr val="202020"/>
+                </a:solidFill>
+              </a:defRPr>
+            </a:pPr>
+            <a:r>
+              <a:t>Level 1</a:t>
+            </a:r>
+          </a:p>
+        </p:txBody>
+      </p:sp>
     </p:spTree>
   </p:cSld>
   <p:clrMapOvr>

</xml_diff>